<commit_message>
update train the trainer w ALS only
</commit_message>
<xml_diff>
--- a/docs/free-rwe-resources/train-the-trainer/training/day-00-environment/kit/Instructor-Deck-with-Notes.pptx
+++ b/docs/free-rwe-resources/train-the-trainer/training/day-00-environment/kit/Instructor-Deck-with-Notes.pptx
@@ -4159,7 +4159,7 @@
             </a:pPr>
             <a:r>
               <a:rPr sz="2200"/>
-              <a:t>3.  Search for 'Metformin' — add it to the set with Include Descendants ON</a:t>
+              <a:t>3.  Search for 'riluzole' — add it to the set with Include Descendants ON</a:t>
             </a:r>
           </a:p>
           <a:p>
@@ -4454,7 +4454,7 @@
             <a:pPr/>
             <a:r>
               <a:rPr sz="2200"/>
-              <a:t>What to verify today: open athena.ohdsi.org and search for 'Metformin'</a:t>
+              <a:t>What to verify today: open athena.ohdsi.org and search for 'riluzole'</a:t>
             </a:r>
           </a:p>
           <a:p>

</xml_diff>